<commit_message>
docs: update architecture PPTX with dispute and billing flow diagrams
- Add slide 9: Fluxo de Disputa/Chargeback (virtual pot reversal, XP removal, ops escalation)
- Add slide 10: Fluxo de Billing/Revenue Share (D+5 cycle, 4 line items, R$132k example)
- PPTX now has 10 slides (was 8)
- Add corresponding PNG files

Co-Authored-By: Claude Opus 4.6 (1M context) <noreply@anthropic.com>
</commit_message>
<xml_diff>
--- a/docs/arquitetura/granix-arquitetura-tecnica.pptx
+++ b/docs/arquitetura/granix-arquitetura-tecnica.pptx
@@ -13,6 +13,8 @@
     <p:sldId id="261" r:id="rId12"/>
     <p:sldId id="262" r:id="rId13"/>
     <p:sldId id="263" r:id="rId14"/>
+    <p:sldId id="264" r:id="rId15"/>
+    <p:sldId id="265" r:id="rId16"/>
   </p:sldIdLst>
   <p:sldSz cx="12191695" cy="6858000" type="screen4x3"/>
   <p:notesSz cx="6858000" cy="9144000"/>
@@ -3127,6 +3129,48 @@
 </p:sld>
 </file>
 
+<file path=ppt/slides/slide10.xml><?xml version="1.0" encoding="utf-8"?>
+<p:sld xmlns:a="http://schemas.openxmlformats.org/drawingml/2006/main" xmlns:p="http://schemas.openxmlformats.org/presentationml/2006/main" xmlns:r="http://schemas.openxmlformats.org/officeDocument/2006/relationships">
+  <p:cSld>
+    <p:spTree>
+      <p:nvGrpSpPr>
+        <p:cNvPr id="1" name=""/>
+        <p:cNvGrpSpPr/>
+        <p:nvPr/>
+      </p:nvGrpSpPr>
+      <p:grpSpPr/>
+      <p:pic>
+        <p:nvPicPr>
+          <p:cNvPr id="2" name="Picture 1" descr="10-flow-billing.png"/>
+          <p:cNvPicPr>
+            <a:picLocks noChangeAspect="1"/>
+          </p:cNvPicPr>
+          <p:nvPr/>
+        </p:nvPicPr>
+        <p:blipFill>
+          <a:blip r:embed="rId2"/>
+          <a:stretch>
+            <a:fillRect/>
+          </a:stretch>
+        </p:blipFill>
+        <p:spPr>
+          <a:xfrm>
+            <a:off x="300355" y="0"/>
+            <a:ext cx="11590985" cy="6858000"/>
+          </a:xfrm>
+          <a:prstGeom prst="rect">
+            <a:avLst/>
+          </a:prstGeom>
+        </p:spPr>
+      </p:pic>
+    </p:spTree>
+  </p:cSld>
+  <p:clrMapOvr>
+    <a:masterClrMapping/>
+  </p:clrMapOvr>
+</p:sld>
+</file>
+
 <file path=ppt/slides/slide2.xml><?xml version="1.0" encoding="utf-8"?>
 <p:sld xmlns:a="http://schemas.openxmlformats.org/drawingml/2006/main" xmlns:p="http://schemas.openxmlformats.org/presentationml/2006/main" xmlns:r="http://schemas.openxmlformats.org/officeDocument/2006/relationships">
   <p:cSld>
@@ -3392,6 +3436,48 @@
       <p:pic>
         <p:nvPicPr>
           <p:cNvPr id="2" name="Picture 1" descr="08-security.png"/>
+          <p:cNvPicPr>
+            <a:picLocks noChangeAspect="1"/>
+          </p:cNvPicPr>
+          <p:nvPr/>
+        </p:nvPicPr>
+        <p:blipFill>
+          <a:blip r:embed="rId2"/>
+          <a:stretch>
+            <a:fillRect/>
+          </a:stretch>
+        </p:blipFill>
+        <p:spPr>
+          <a:xfrm>
+            <a:off x="0" y="86"/>
+            <a:ext cx="12191695" cy="6857828"/>
+          </a:xfrm>
+          <a:prstGeom prst="rect">
+            <a:avLst/>
+          </a:prstGeom>
+        </p:spPr>
+      </p:pic>
+    </p:spTree>
+  </p:cSld>
+  <p:clrMapOvr>
+    <a:masterClrMapping/>
+  </p:clrMapOvr>
+</p:sld>
+</file>
+
+<file path=ppt/slides/slide9.xml><?xml version="1.0" encoding="utf-8"?>
+<p:sld xmlns:a="http://schemas.openxmlformats.org/drawingml/2006/main" xmlns:p="http://schemas.openxmlformats.org/presentationml/2006/main" xmlns:r="http://schemas.openxmlformats.org/officeDocument/2006/relationships">
+  <p:cSld>
+    <p:spTree>
+      <p:nvGrpSpPr>
+        <p:cNvPr id="1" name=""/>
+        <p:cNvGrpSpPr/>
+        <p:nvPr/>
+      </p:nvGrpSpPr>
+      <p:grpSpPr/>
+      <p:pic>
+        <p:nvPicPr>
+          <p:cNvPr id="2" name="Picture 1" descr="09-flow-dispute.png"/>
           <p:cNvPicPr>
             <a:picLocks noChangeAspect="1"/>
           </p:cNvPicPr>

</xml_diff>

<commit_message>
refactor: move v2 specs to docs/specs/, update references
Co-Authored-By: Claude Opus 4.6 (1M context) <noreply@anthropic.com>
</commit_message>
<xml_diff>
--- a/docs/arquitetura/granix-arquitetura-tecnica.pptx
+++ b/docs/arquitetura/granix-arquitetura-tecnica.pptx
@@ -5,18 +5,18 @@
     <p:sldMasterId id="2147483648" r:id="rId1"/>
   </p:sldMasterIdLst>
   <p:sldIdLst>
-    <p:sldId id="256" r:id="rId7"/>
-    <p:sldId id="257" r:id="rId8"/>
-    <p:sldId id="258" r:id="rId9"/>
-    <p:sldId id="259" r:id="rId10"/>
-    <p:sldId id="260" r:id="rId11"/>
-    <p:sldId id="261" r:id="rId12"/>
-    <p:sldId id="262" r:id="rId13"/>
-    <p:sldId id="263" r:id="rId14"/>
-    <p:sldId id="264" r:id="rId15"/>
-    <p:sldId id="265" r:id="rId16"/>
+    <p:sldId id="256" r:id="rId2"/>
+    <p:sldId id="257" r:id="rId3"/>
+    <p:sldId id="258" r:id="rId4"/>
+    <p:sldId id="259" r:id="rId5"/>
+    <p:sldId id="260" r:id="rId6"/>
+    <p:sldId id="261" r:id="rId7"/>
+    <p:sldId id="262" r:id="rId8"/>
+    <p:sldId id="263" r:id="rId9"/>
+    <p:sldId id="264" r:id="rId10"/>
+    <p:sldId id="265" r:id="rId11"/>
   </p:sldIdLst>
-  <p:sldSz cx="12191695" cy="6858000" type="screen4x3"/>
+  <p:sldSz cx="12192000" cy="6858000"/>
   <p:notesSz cx="6858000" cy="9144000"/>
   <p:defaultTextStyle>
     <a:defPPr>
@@ -113,6 +113,22 @@
       </a:defRPr>
     </a:lvl9pPr>
   </p:defaultTextStyle>
+  <p:extLst>
+    <p:ext uri="{EFAFB233-063F-42B5-8137-9DF3F51BA10A}">
+      <p15:sldGuideLst xmlns:p15="http://schemas.microsoft.com/office/powerpoint/2012/main">
+        <p15:guide id="1" orient="horz" pos="2160">
+          <p15:clr>
+            <a:srgbClr val="A4A3A4"/>
+          </p15:clr>
+        </p15:guide>
+        <p15:guide id="2" pos="2880">
+          <p15:clr>
+            <a:srgbClr val="A4A3A4"/>
+          </p15:clr>
+        </p15:guide>
+      </p15:sldGuideLst>
+    </p:ext>
+  </p:extLst>
 </p:presentation>
 </file>
 
@@ -154,10 +170,9 @@
           <a:lstStyle/>
           <a:p>
             <a:r>
-              <a:rPr lang="en-US" smtClean="0"/>
+              <a:rPr lang="en-US"/>
               <a:t>Click to edit Master title style</a:t>
             </a:r>
-            <a:endParaRPr lang="en-US"/>
           </a:p>
         </p:txBody>
       </p:sp>
@@ -273,10 +288,9 @@
           </a:lstStyle>
           <a:p>
             <a:r>
-              <a:rPr lang="en-US" smtClean="0"/>
+              <a:rPr lang="en-US"/>
               <a:t>Click to edit Master subtitle style</a:t>
             </a:r>
-            <a:endParaRPr lang="en-US"/>
           </a:p>
         </p:txBody>
       </p:sp>
@@ -297,7 +311,7 @@
           <a:p>
             <a:fld id="{5BCAD085-E8A6-8845-BD4E-CB4CCA059FC4}" type="datetimeFigureOut">
               <a:rPr lang="en-US" smtClean="0"/>
-              <a:t>1/27/13</a:t>
+              <a:t>4/2/26</a:t>
             </a:fld>
             <a:endParaRPr lang="en-US"/>
           </a:p>
@@ -339,7 +353,7 @@
           <a:p>
             <a:fld id="{C1FF6DA9-008F-8B48-92A6-B652298478BF}" type="slidenum">
               <a:rPr lang="en-US" smtClean="0"/>
-              <a:t>‹#›</a:t>
+              <a:t>‹nº›</a:t>
             </a:fld>
             <a:endParaRPr lang="en-US"/>
           </a:p>
@@ -391,10 +405,9 @@
           <a:lstStyle/>
           <a:p>
             <a:r>
-              <a:rPr lang="en-US" smtClean="0"/>
+              <a:rPr lang="en-US"/>
               <a:t>Click to edit Master title style</a:t>
             </a:r>
-            <a:endParaRPr lang="en-US"/>
           </a:p>
         </p:txBody>
       </p:sp>
@@ -415,38 +428,37 @@
           <a:p>
             <a:pPr lvl="0"/>
             <a:r>
-              <a:rPr lang="en-US" smtClean="0"/>
+              <a:rPr lang="en-US"/>
               <a:t>Click to edit Master text styles</a:t>
             </a:r>
           </a:p>
           <a:p>
             <a:pPr lvl="1"/>
             <a:r>
-              <a:rPr lang="en-US" smtClean="0"/>
+              <a:rPr lang="en-US"/>
               <a:t>Second level</a:t>
             </a:r>
           </a:p>
           <a:p>
             <a:pPr lvl="2"/>
             <a:r>
-              <a:rPr lang="en-US" smtClean="0"/>
+              <a:rPr lang="en-US"/>
               <a:t>Third level</a:t>
             </a:r>
           </a:p>
           <a:p>
             <a:pPr lvl="3"/>
             <a:r>
-              <a:rPr lang="en-US" smtClean="0"/>
+              <a:rPr lang="en-US"/>
               <a:t>Fourth level</a:t>
             </a:r>
           </a:p>
           <a:p>
             <a:pPr lvl="4"/>
             <a:r>
-              <a:rPr lang="en-US" smtClean="0"/>
+              <a:rPr lang="en-US"/>
               <a:t>Fifth level</a:t>
             </a:r>
-            <a:endParaRPr lang="en-US"/>
           </a:p>
         </p:txBody>
       </p:sp>
@@ -467,7 +479,7 @@
           <a:p>
             <a:fld id="{5BCAD085-E8A6-8845-BD4E-CB4CCA059FC4}" type="datetimeFigureOut">
               <a:rPr lang="en-US" smtClean="0"/>
-              <a:t>1/27/13</a:t>
+              <a:t>4/2/26</a:t>
             </a:fld>
             <a:endParaRPr lang="en-US"/>
           </a:p>
@@ -509,7 +521,7 @@
           <a:p>
             <a:fld id="{C1FF6DA9-008F-8B48-92A6-B652298478BF}" type="slidenum">
               <a:rPr lang="en-US" smtClean="0"/>
-              <a:t>‹#›</a:t>
+              <a:t>‹nº›</a:t>
             </a:fld>
             <a:endParaRPr lang="en-US"/>
           </a:p>
@@ -566,10 +578,9 @@
           <a:lstStyle/>
           <a:p>
             <a:r>
-              <a:rPr lang="en-US" smtClean="0"/>
+              <a:rPr lang="en-US"/>
               <a:t>Click to edit Master title style</a:t>
             </a:r>
-            <a:endParaRPr lang="en-US"/>
           </a:p>
         </p:txBody>
       </p:sp>
@@ -595,38 +606,37 @@
           <a:p>
             <a:pPr lvl="0"/>
             <a:r>
-              <a:rPr lang="en-US" smtClean="0"/>
+              <a:rPr lang="en-US"/>
               <a:t>Click to edit Master text styles</a:t>
             </a:r>
           </a:p>
           <a:p>
             <a:pPr lvl="1"/>
             <a:r>
-              <a:rPr lang="en-US" smtClean="0"/>
+              <a:rPr lang="en-US"/>
               <a:t>Second level</a:t>
             </a:r>
           </a:p>
           <a:p>
             <a:pPr lvl="2"/>
             <a:r>
-              <a:rPr lang="en-US" smtClean="0"/>
+              <a:rPr lang="en-US"/>
               <a:t>Third level</a:t>
             </a:r>
           </a:p>
           <a:p>
             <a:pPr lvl="3"/>
             <a:r>
-              <a:rPr lang="en-US" smtClean="0"/>
+              <a:rPr lang="en-US"/>
               <a:t>Fourth level</a:t>
             </a:r>
           </a:p>
           <a:p>
             <a:pPr lvl="4"/>
             <a:r>
-              <a:rPr lang="en-US" smtClean="0"/>
+              <a:rPr lang="en-US"/>
               <a:t>Fifth level</a:t>
             </a:r>
-            <a:endParaRPr lang="en-US"/>
           </a:p>
         </p:txBody>
       </p:sp>
@@ -647,7 +657,7 @@
           <a:p>
             <a:fld id="{5BCAD085-E8A6-8845-BD4E-CB4CCA059FC4}" type="datetimeFigureOut">
               <a:rPr lang="en-US" smtClean="0"/>
-              <a:t>1/27/13</a:t>
+              <a:t>4/2/26</a:t>
             </a:fld>
             <a:endParaRPr lang="en-US"/>
           </a:p>
@@ -689,7 +699,7 @@
           <a:p>
             <a:fld id="{C1FF6DA9-008F-8B48-92A6-B652298478BF}" type="slidenum">
               <a:rPr lang="en-US" smtClean="0"/>
-              <a:t>‹#›</a:t>
+              <a:t>‹nº›</a:t>
             </a:fld>
             <a:endParaRPr lang="en-US"/>
           </a:p>
@@ -741,10 +751,9 @@
           <a:lstStyle/>
           <a:p>
             <a:r>
-              <a:rPr lang="en-US" smtClean="0"/>
+              <a:rPr lang="en-US"/>
               <a:t>Click to edit Master title style</a:t>
             </a:r>
-            <a:endParaRPr lang="en-US"/>
           </a:p>
         </p:txBody>
       </p:sp>
@@ -765,38 +774,37 @@
           <a:p>
             <a:pPr lvl="0"/>
             <a:r>
-              <a:rPr lang="en-US" smtClean="0"/>
+              <a:rPr lang="en-US"/>
               <a:t>Click to edit Master text styles</a:t>
             </a:r>
           </a:p>
           <a:p>
             <a:pPr lvl="1"/>
             <a:r>
-              <a:rPr lang="en-US" smtClean="0"/>
+              <a:rPr lang="en-US"/>
               <a:t>Second level</a:t>
             </a:r>
           </a:p>
           <a:p>
             <a:pPr lvl="2"/>
             <a:r>
-              <a:rPr lang="en-US" smtClean="0"/>
+              <a:rPr lang="en-US"/>
               <a:t>Third level</a:t>
             </a:r>
           </a:p>
           <a:p>
             <a:pPr lvl="3"/>
             <a:r>
-              <a:rPr lang="en-US" smtClean="0"/>
+              <a:rPr lang="en-US"/>
               <a:t>Fourth level</a:t>
             </a:r>
           </a:p>
           <a:p>
             <a:pPr lvl="4"/>
             <a:r>
-              <a:rPr lang="en-US" smtClean="0"/>
+              <a:rPr lang="en-US"/>
               <a:t>Fifth level</a:t>
             </a:r>
-            <a:endParaRPr lang="en-US"/>
           </a:p>
         </p:txBody>
       </p:sp>
@@ -817,7 +825,7 @@
           <a:p>
             <a:fld id="{5BCAD085-E8A6-8845-BD4E-CB4CCA059FC4}" type="datetimeFigureOut">
               <a:rPr lang="en-US" smtClean="0"/>
-              <a:t>1/27/13</a:t>
+              <a:t>4/2/26</a:t>
             </a:fld>
             <a:endParaRPr lang="en-US"/>
           </a:p>
@@ -859,7 +867,7 @@
           <a:p>
             <a:fld id="{C1FF6DA9-008F-8B48-92A6-B652298478BF}" type="slidenum">
               <a:rPr lang="en-US" smtClean="0"/>
-              <a:t>‹#›</a:t>
+              <a:t>‹nº›</a:t>
             </a:fld>
             <a:endParaRPr lang="en-US"/>
           </a:p>
@@ -920,10 +928,9 @@
           </a:lstStyle>
           <a:p>
             <a:r>
-              <a:rPr lang="en-US" smtClean="0"/>
+              <a:rPr lang="en-US"/>
               <a:t>Click to edit Master title style</a:t>
             </a:r>
-            <a:endParaRPr lang="en-US"/>
           </a:p>
         </p:txBody>
       </p:sp>
@@ -1040,7 +1047,7 @@
           <a:p>
             <a:pPr lvl="0"/>
             <a:r>
-              <a:rPr lang="en-US" smtClean="0"/>
+              <a:rPr lang="en-US"/>
               <a:t>Click to edit Master text styles</a:t>
             </a:r>
           </a:p>
@@ -1063,7 +1070,7 @@
           <a:p>
             <a:fld id="{5BCAD085-E8A6-8845-BD4E-CB4CCA059FC4}" type="datetimeFigureOut">
               <a:rPr lang="en-US" smtClean="0"/>
-              <a:t>1/27/13</a:t>
+              <a:t>4/2/26</a:t>
             </a:fld>
             <a:endParaRPr lang="en-US"/>
           </a:p>
@@ -1105,7 +1112,7 @@
           <a:p>
             <a:fld id="{C1FF6DA9-008F-8B48-92A6-B652298478BF}" type="slidenum">
               <a:rPr lang="en-US" smtClean="0"/>
-              <a:t>‹#›</a:t>
+              <a:t>‹nº›</a:t>
             </a:fld>
             <a:endParaRPr lang="en-US"/>
           </a:p>
@@ -1157,10 +1164,9 @@
           <a:lstStyle/>
           <a:p>
             <a:r>
-              <a:rPr lang="en-US" smtClean="0"/>
+              <a:rPr lang="en-US"/>
               <a:t>Click to edit Master title style</a:t>
             </a:r>
-            <a:endParaRPr lang="en-US"/>
           </a:p>
         </p:txBody>
       </p:sp>
@@ -1214,38 +1220,37 @@
           <a:p>
             <a:pPr lvl="0"/>
             <a:r>
-              <a:rPr lang="en-US" smtClean="0"/>
+              <a:rPr lang="en-US"/>
               <a:t>Click to edit Master text styles</a:t>
             </a:r>
           </a:p>
           <a:p>
             <a:pPr lvl="1"/>
             <a:r>
-              <a:rPr lang="en-US" smtClean="0"/>
+              <a:rPr lang="en-US"/>
               <a:t>Second level</a:t>
             </a:r>
           </a:p>
           <a:p>
             <a:pPr lvl="2"/>
             <a:r>
-              <a:rPr lang="en-US" smtClean="0"/>
+              <a:rPr lang="en-US"/>
               <a:t>Third level</a:t>
             </a:r>
           </a:p>
           <a:p>
             <a:pPr lvl="3"/>
             <a:r>
-              <a:rPr lang="en-US" smtClean="0"/>
+              <a:rPr lang="en-US"/>
               <a:t>Fourth level</a:t>
             </a:r>
           </a:p>
           <a:p>
             <a:pPr lvl="4"/>
             <a:r>
-              <a:rPr lang="en-US" smtClean="0"/>
+              <a:rPr lang="en-US"/>
               <a:t>Fifth level</a:t>
             </a:r>
-            <a:endParaRPr lang="en-US"/>
           </a:p>
         </p:txBody>
       </p:sp>
@@ -1299,38 +1304,37 @@
           <a:p>
             <a:pPr lvl="0"/>
             <a:r>
-              <a:rPr lang="en-US" smtClean="0"/>
+              <a:rPr lang="en-US"/>
               <a:t>Click to edit Master text styles</a:t>
             </a:r>
           </a:p>
           <a:p>
             <a:pPr lvl="1"/>
             <a:r>
-              <a:rPr lang="en-US" smtClean="0"/>
+              <a:rPr lang="en-US"/>
               <a:t>Second level</a:t>
             </a:r>
           </a:p>
           <a:p>
             <a:pPr lvl="2"/>
             <a:r>
-              <a:rPr lang="en-US" smtClean="0"/>
+              <a:rPr lang="en-US"/>
               <a:t>Third level</a:t>
             </a:r>
           </a:p>
           <a:p>
             <a:pPr lvl="3"/>
             <a:r>
-              <a:rPr lang="en-US" smtClean="0"/>
+              <a:rPr lang="en-US"/>
               <a:t>Fourth level</a:t>
             </a:r>
           </a:p>
           <a:p>
             <a:pPr lvl="4"/>
             <a:r>
-              <a:rPr lang="en-US" smtClean="0"/>
+              <a:rPr lang="en-US"/>
               <a:t>Fifth level</a:t>
             </a:r>
-            <a:endParaRPr lang="en-US"/>
           </a:p>
         </p:txBody>
       </p:sp>
@@ -1351,7 +1355,7 @@
           <a:p>
             <a:fld id="{5BCAD085-E8A6-8845-BD4E-CB4CCA059FC4}" type="datetimeFigureOut">
               <a:rPr lang="en-US" smtClean="0"/>
-              <a:t>1/27/13</a:t>
+              <a:t>4/2/26</a:t>
             </a:fld>
             <a:endParaRPr lang="en-US"/>
           </a:p>
@@ -1393,7 +1397,7 @@
           <a:p>
             <a:fld id="{C1FF6DA9-008F-8B48-92A6-B652298478BF}" type="slidenum">
               <a:rPr lang="en-US" smtClean="0"/>
-              <a:t>‹#›</a:t>
+              <a:t>‹nº›</a:t>
             </a:fld>
             <a:endParaRPr lang="en-US"/>
           </a:p>
@@ -1449,10 +1453,9 @@
           </a:lstStyle>
           <a:p>
             <a:r>
-              <a:rPr lang="en-US" smtClean="0"/>
+              <a:rPr lang="en-US"/>
               <a:t>Click to edit Master title style</a:t>
             </a:r>
-            <a:endParaRPr lang="en-US"/>
           </a:p>
         </p:txBody>
       </p:sp>
@@ -1515,7 +1518,7 @@
           <a:p>
             <a:pPr lvl="0"/>
             <a:r>
-              <a:rPr lang="en-US" smtClean="0"/>
+              <a:rPr lang="en-US"/>
               <a:t>Click to edit Master text styles</a:t>
             </a:r>
           </a:p>
@@ -1571,38 +1574,37 @@
           <a:p>
             <a:pPr lvl="0"/>
             <a:r>
-              <a:rPr lang="en-US" smtClean="0"/>
+              <a:rPr lang="en-US"/>
               <a:t>Click to edit Master text styles</a:t>
             </a:r>
           </a:p>
           <a:p>
             <a:pPr lvl="1"/>
             <a:r>
-              <a:rPr lang="en-US" smtClean="0"/>
+              <a:rPr lang="en-US"/>
               <a:t>Second level</a:t>
             </a:r>
           </a:p>
           <a:p>
             <a:pPr lvl="2"/>
             <a:r>
-              <a:rPr lang="en-US" smtClean="0"/>
+              <a:rPr lang="en-US"/>
               <a:t>Third level</a:t>
             </a:r>
           </a:p>
           <a:p>
             <a:pPr lvl="3"/>
             <a:r>
-              <a:rPr lang="en-US" smtClean="0"/>
+              <a:rPr lang="en-US"/>
               <a:t>Fourth level</a:t>
             </a:r>
           </a:p>
           <a:p>
             <a:pPr lvl="4"/>
             <a:r>
-              <a:rPr lang="en-US" smtClean="0"/>
+              <a:rPr lang="en-US"/>
               <a:t>Fifth level</a:t>
             </a:r>
-            <a:endParaRPr lang="en-US"/>
           </a:p>
         </p:txBody>
       </p:sp>
@@ -1665,7 +1667,7 @@
           <a:p>
             <a:pPr lvl="0"/>
             <a:r>
-              <a:rPr lang="en-US" smtClean="0"/>
+              <a:rPr lang="en-US"/>
               <a:t>Click to edit Master text styles</a:t>
             </a:r>
           </a:p>
@@ -1721,38 +1723,37 @@
           <a:p>
             <a:pPr lvl="0"/>
             <a:r>
-              <a:rPr lang="en-US" smtClean="0"/>
+              <a:rPr lang="en-US"/>
               <a:t>Click to edit Master text styles</a:t>
             </a:r>
           </a:p>
           <a:p>
             <a:pPr lvl="1"/>
             <a:r>
-              <a:rPr lang="en-US" smtClean="0"/>
+              <a:rPr lang="en-US"/>
               <a:t>Second level</a:t>
             </a:r>
           </a:p>
           <a:p>
             <a:pPr lvl="2"/>
             <a:r>
-              <a:rPr lang="en-US" smtClean="0"/>
+              <a:rPr lang="en-US"/>
               <a:t>Third level</a:t>
             </a:r>
           </a:p>
           <a:p>
             <a:pPr lvl="3"/>
             <a:r>
-              <a:rPr lang="en-US" smtClean="0"/>
+              <a:rPr lang="en-US"/>
               <a:t>Fourth level</a:t>
             </a:r>
           </a:p>
           <a:p>
             <a:pPr lvl="4"/>
             <a:r>
-              <a:rPr lang="en-US" smtClean="0"/>
+              <a:rPr lang="en-US"/>
               <a:t>Fifth level</a:t>
             </a:r>
-            <a:endParaRPr lang="en-US"/>
           </a:p>
         </p:txBody>
       </p:sp>
@@ -1773,7 +1774,7 @@
           <a:p>
             <a:fld id="{5BCAD085-E8A6-8845-BD4E-CB4CCA059FC4}" type="datetimeFigureOut">
               <a:rPr lang="en-US" smtClean="0"/>
-              <a:t>1/27/13</a:t>
+              <a:t>4/2/26</a:t>
             </a:fld>
             <a:endParaRPr lang="en-US"/>
           </a:p>
@@ -1815,7 +1816,7 @@
           <a:p>
             <a:fld id="{C1FF6DA9-008F-8B48-92A6-B652298478BF}" type="slidenum">
               <a:rPr lang="en-US" smtClean="0"/>
-              <a:t>‹#›</a:t>
+              <a:t>‹nº›</a:t>
             </a:fld>
             <a:endParaRPr lang="en-US"/>
           </a:p>
@@ -1867,10 +1868,9 @@
           <a:lstStyle/>
           <a:p>
             <a:r>
-              <a:rPr lang="en-US" smtClean="0"/>
+              <a:rPr lang="en-US"/>
               <a:t>Click to edit Master title style</a:t>
             </a:r>
-            <a:endParaRPr lang="en-US"/>
           </a:p>
         </p:txBody>
       </p:sp>
@@ -1891,7 +1891,7 @@
           <a:p>
             <a:fld id="{5BCAD085-E8A6-8845-BD4E-CB4CCA059FC4}" type="datetimeFigureOut">
               <a:rPr lang="en-US" smtClean="0"/>
-              <a:t>1/27/13</a:t>
+              <a:t>4/2/26</a:t>
             </a:fld>
             <a:endParaRPr lang="en-US"/>
           </a:p>
@@ -1933,7 +1933,7 @@
           <a:p>
             <a:fld id="{C1FF6DA9-008F-8B48-92A6-B652298478BF}" type="slidenum">
               <a:rPr lang="en-US" smtClean="0"/>
-              <a:t>‹#›</a:t>
+              <a:t>‹nº›</a:t>
             </a:fld>
             <a:endParaRPr lang="en-US"/>
           </a:p>
@@ -1986,7 +1986,7 @@
           <a:p>
             <a:fld id="{5BCAD085-E8A6-8845-BD4E-CB4CCA059FC4}" type="datetimeFigureOut">
               <a:rPr lang="en-US" smtClean="0"/>
-              <a:t>1/27/13</a:t>
+              <a:t>4/2/26</a:t>
             </a:fld>
             <a:endParaRPr lang="en-US"/>
           </a:p>
@@ -2028,7 +2028,7 @@
           <a:p>
             <a:fld id="{C1FF6DA9-008F-8B48-92A6-B652298478BF}" type="slidenum">
               <a:rPr lang="en-US" smtClean="0"/>
-              <a:t>‹#›</a:t>
+              <a:t>‹nº›</a:t>
             </a:fld>
             <a:endParaRPr lang="en-US"/>
           </a:p>
@@ -2089,10 +2089,9 @@
           </a:lstStyle>
           <a:p>
             <a:r>
-              <a:rPr lang="en-US" smtClean="0"/>
+              <a:rPr lang="en-US"/>
               <a:t>Click to edit Master title style</a:t>
             </a:r>
-            <a:endParaRPr lang="en-US"/>
           </a:p>
         </p:txBody>
       </p:sp>
@@ -2146,38 +2145,37 @@
           <a:p>
             <a:pPr lvl="0"/>
             <a:r>
-              <a:rPr lang="en-US" smtClean="0"/>
+              <a:rPr lang="en-US"/>
               <a:t>Click to edit Master text styles</a:t>
             </a:r>
           </a:p>
           <a:p>
             <a:pPr lvl="1"/>
             <a:r>
-              <a:rPr lang="en-US" smtClean="0"/>
+              <a:rPr lang="en-US"/>
               <a:t>Second level</a:t>
             </a:r>
           </a:p>
           <a:p>
             <a:pPr lvl="2"/>
             <a:r>
-              <a:rPr lang="en-US" smtClean="0"/>
+              <a:rPr lang="en-US"/>
               <a:t>Third level</a:t>
             </a:r>
           </a:p>
           <a:p>
             <a:pPr lvl="3"/>
             <a:r>
-              <a:rPr lang="en-US" smtClean="0"/>
+              <a:rPr lang="en-US"/>
               <a:t>Fourth level</a:t>
             </a:r>
           </a:p>
           <a:p>
             <a:pPr lvl="4"/>
             <a:r>
-              <a:rPr lang="en-US" smtClean="0"/>
+              <a:rPr lang="en-US"/>
               <a:t>Fifth level</a:t>
             </a:r>
-            <a:endParaRPr lang="en-US"/>
           </a:p>
         </p:txBody>
       </p:sp>
@@ -2240,7 +2238,7 @@
           <a:p>
             <a:pPr lvl="0"/>
             <a:r>
-              <a:rPr lang="en-US" smtClean="0"/>
+              <a:rPr lang="en-US"/>
               <a:t>Click to edit Master text styles</a:t>
             </a:r>
           </a:p>
@@ -2263,7 +2261,7 @@
           <a:p>
             <a:fld id="{5BCAD085-E8A6-8845-BD4E-CB4CCA059FC4}" type="datetimeFigureOut">
               <a:rPr lang="en-US" smtClean="0"/>
-              <a:t>1/27/13</a:t>
+              <a:t>4/2/26</a:t>
             </a:fld>
             <a:endParaRPr lang="en-US"/>
           </a:p>
@@ -2305,7 +2303,7 @@
           <a:p>
             <a:fld id="{C1FF6DA9-008F-8B48-92A6-B652298478BF}" type="slidenum">
               <a:rPr lang="en-US" smtClean="0"/>
-              <a:t>‹#›</a:t>
+              <a:t>‹nº›</a:t>
             </a:fld>
             <a:endParaRPr lang="en-US"/>
           </a:p>
@@ -2366,10 +2364,9 @@
           </a:lstStyle>
           <a:p>
             <a:r>
-              <a:rPr lang="en-US" smtClean="0"/>
+              <a:rPr lang="en-US"/>
               <a:t>Click to edit Master title style</a:t>
             </a:r>
-            <a:endParaRPr lang="en-US"/>
           </a:p>
         </p:txBody>
       </p:sp>
@@ -2493,7 +2490,7 @@
           <a:p>
             <a:pPr lvl="0"/>
             <a:r>
-              <a:rPr lang="en-US" smtClean="0"/>
+              <a:rPr lang="en-US"/>
               <a:t>Click to edit Master text styles</a:t>
             </a:r>
           </a:p>
@@ -2516,7 +2513,7 @@
           <a:p>
             <a:fld id="{5BCAD085-E8A6-8845-BD4E-CB4CCA059FC4}" type="datetimeFigureOut">
               <a:rPr lang="en-US" smtClean="0"/>
-              <a:t>1/27/13</a:t>
+              <a:t>4/2/26</a:t>
             </a:fld>
             <a:endParaRPr lang="en-US"/>
           </a:p>
@@ -2558,7 +2555,7 @@
           <a:p>
             <a:fld id="{C1FF6DA9-008F-8B48-92A6-B652298478BF}" type="slidenum">
               <a:rPr lang="en-US" smtClean="0"/>
-              <a:t>‹#›</a:t>
+              <a:t>‹nº›</a:t>
             </a:fld>
             <a:endParaRPr lang="en-US"/>
           </a:p>
@@ -2625,10 +2622,9 @@
           <a:lstStyle/>
           <a:p>
             <a:r>
-              <a:rPr lang="en-US" smtClean="0"/>
+              <a:rPr lang="en-US"/>
               <a:t>Click to edit Master title style</a:t>
             </a:r>
-            <a:endParaRPr lang="en-US"/>
           </a:p>
         </p:txBody>
       </p:sp>
@@ -2659,38 +2655,37 @@
           <a:p>
             <a:pPr lvl="0"/>
             <a:r>
-              <a:rPr lang="en-US" smtClean="0"/>
+              <a:rPr lang="en-US"/>
               <a:t>Click to edit Master text styles</a:t>
             </a:r>
           </a:p>
           <a:p>
             <a:pPr lvl="1"/>
             <a:r>
-              <a:rPr lang="en-US" smtClean="0"/>
+              <a:rPr lang="en-US"/>
               <a:t>Second level</a:t>
             </a:r>
           </a:p>
           <a:p>
             <a:pPr lvl="2"/>
             <a:r>
-              <a:rPr lang="en-US" smtClean="0"/>
+              <a:rPr lang="en-US"/>
               <a:t>Third level</a:t>
             </a:r>
           </a:p>
           <a:p>
             <a:pPr lvl="3"/>
             <a:r>
-              <a:rPr lang="en-US" smtClean="0"/>
+              <a:rPr lang="en-US"/>
               <a:t>Fourth level</a:t>
             </a:r>
           </a:p>
           <a:p>
             <a:pPr lvl="4"/>
             <a:r>
-              <a:rPr lang="en-US" smtClean="0"/>
+              <a:rPr lang="en-US"/>
               <a:t>Fifth level</a:t>
             </a:r>
-            <a:endParaRPr lang="en-US"/>
           </a:p>
         </p:txBody>
       </p:sp>
@@ -2729,7 +2724,7 @@
           <a:p>
             <a:fld id="{5BCAD085-E8A6-8845-BD4E-CB4CCA059FC4}" type="datetimeFigureOut">
               <a:rPr lang="en-US" smtClean="0"/>
-              <a:t>1/27/13</a:t>
+              <a:t>4/2/26</a:t>
             </a:fld>
             <a:endParaRPr lang="en-US"/>
           </a:p>
@@ -2807,7 +2802,7 @@
           <a:p>
             <a:fld id="{C1FF6DA9-008F-8B48-92A6-B652298478BF}" type="slidenum">
               <a:rPr lang="en-US" smtClean="0"/>
-              <a:t>‹#›</a:t>
+              <a:t>‹nº›</a:t>
             </a:fld>
             <a:endParaRPr lang="en-US"/>
           </a:p>
@@ -3088,7 +3083,7 @@
 </file>
 
 <file path=ppt/slides/slide1.xml><?xml version="1.0" encoding="utf-8"?>
-<p:sld xmlns:a="http://schemas.openxmlformats.org/drawingml/2006/main" xmlns:p="http://schemas.openxmlformats.org/presentationml/2006/main" xmlns:r="http://schemas.openxmlformats.org/officeDocument/2006/relationships">
+<p:sld xmlns:a="http://schemas.openxmlformats.org/drawingml/2006/main" xmlns:r="http://schemas.openxmlformats.org/officeDocument/2006/relationships" xmlns:p="http://schemas.openxmlformats.org/presentationml/2006/main">
   <p:cSld>
     <p:spTree>
       <p:nvGrpSpPr>
@@ -3096,7 +3091,14 @@
         <p:cNvGrpSpPr/>
         <p:nvPr/>
       </p:nvGrpSpPr>
-      <p:grpSpPr/>
+      <p:grpSpPr>
+        <a:xfrm>
+          <a:off x="0" y="0"/>
+          <a:ext cx="0" cy="0"/>
+          <a:chOff x="0" y="0"/>
+          <a:chExt cx="0" cy="0"/>
+        </a:xfrm>
+      </p:grpSpPr>
       <p:pic>
         <p:nvPicPr>
           <p:cNvPr id="2" name="Picture 1" descr="01-c4-container.png"/>
@@ -3130,7 +3132,7 @@
 </file>
 
 <file path=ppt/slides/slide10.xml><?xml version="1.0" encoding="utf-8"?>
-<p:sld xmlns:a="http://schemas.openxmlformats.org/drawingml/2006/main" xmlns:p="http://schemas.openxmlformats.org/presentationml/2006/main" xmlns:r="http://schemas.openxmlformats.org/officeDocument/2006/relationships">
+<p:sld xmlns:a="http://schemas.openxmlformats.org/drawingml/2006/main" xmlns:r="http://schemas.openxmlformats.org/officeDocument/2006/relationships" xmlns:p="http://schemas.openxmlformats.org/presentationml/2006/main">
   <p:cSld>
     <p:spTree>
       <p:nvGrpSpPr>
@@ -3138,7 +3140,14 @@
         <p:cNvGrpSpPr/>
         <p:nvPr/>
       </p:nvGrpSpPr>
-      <p:grpSpPr/>
+      <p:grpSpPr>
+        <a:xfrm>
+          <a:off x="0" y="0"/>
+          <a:ext cx="0" cy="0"/>
+          <a:chOff x="0" y="0"/>
+          <a:chExt cx="0" cy="0"/>
+        </a:xfrm>
+      </p:grpSpPr>
       <p:pic>
         <p:nvPicPr>
           <p:cNvPr id="2" name="Picture 1" descr="10-flow-billing.png"/>
@@ -3172,7 +3181,7 @@
 </file>
 
 <file path=ppt/slides/slide2.xml><?xml version="1.0" encoding="utf-8"?>
-<p:sld xmlns:a="http://schemas.openxmlformats.org/drawingml/2006/main" xmlns:p="http://schemas.openxmlformats.org/presentationml/2006/main" xmlns:r="http://schemas.openxmlformats.org/officeDocument/2006/relationships">
+<p:sld xmlns:a="http://schemas.openxmlformats.org/drawingml/2006/main" xmlns:r="http://schemas.openxmlformats.org/officeDocument/2006/relationships" xmlns:p="http://schemas.openxmlformats.org/presentationml/2006/main">
   <p:cSld>
     <p:spTree>
       <p:nvGrpSpPr>
@@ -3180,7 +3189,14 @@
         <p:cNvGrpSpPr/>
         <p:nvPr/>
       </p:nvGrpSpPr>
-      <p:grpSpPr/>
+      <p:grpSpPr>
+        <a:xfrm>
+          <a:off x="0" y="0"/>
+          <a:ext cx="0" cy="0"/>
+          <a:chOff x="0" y="0"/>
+          <a:chExt cx="0" cy="0"/>
+        </a:xfrm>
+      </p:grpSpPr>
       <p:pic>
         <p:nvPicPr>
           <p:cNvPr id="2" name="Picture 1" descr="02-integration-options.png"/>
@@ -3214,7 +3230,7 @@
 </file>
 
 <file path=ppt/slides/slide3.xml><?xml version="1.0" encoding="utf-8"?>
-<p:sld xmlns:a="http://schemas.openxmlformats.org/drawingml/2006/main" xmlns:p="http://schemas.openxmlformats.org/presentationml/2006/main" xmlns:r="http://schemas.openxmlformats.org/officeDocument/2006/relationships">
+<p:sld xmlns:a="http://schemas.openxmlformats.org/drawingml/2006/main" xmlns:r="http://schemas.openxmlformats.org/officeDocument/2006/relationships" xmlns:p="http://schemas.openxmlformats.org/presentationml/2006/main">
   <p:cSld>
     <p:spTree>
       <p:nvGrpSpPr>
@@ -3222,7 +3238,14 @@
         <p:cNvGrpSpPr/>
         <p:nvPr/>
       </p:nvGrpSpPr>
-      <p:grpSpPr/>
+      <p:grpSpPr>
+        <a:xfrm>
+          <a:off x="0" y="0"/>
+          <a:ext cx="0" cy="0"/>
+          <a:chOff x="0" y="0"/>
+          <a:chExt cx="0" cy="0"/>
+        </a:xfrm>
+      </p:grpSpPr>
       <p:pic>
         <p:nvPicPr>
           <p:cNvPr id="2" name="Picture 1" descr="03-flow-tasks.png"/>
@@ -3256,7 +3279,7 @@
 </file>
 
 <file path=ppt/slides/slide4.xml><?xml version="1.0" encoding="utf-8"?>
-<p:sld xmlns:a="http://schemas.openxmlformats.org/drawingml/2006/main" xmlns:p="http://schemas.openxmlformats.org/presentationml/2006/main" xmlns:r="http://schemas.openxmlformats.org/officeDocument/2006/relationships">
+<p:sld xmlns:a="http://schemas.openxmlformats.org/drawingml/2006/main" xmlns:r="http://schemas.openxmlformats.org/officeDocument/2006/relationships" xmlns:p="http://schemas.openxmlformats.org/presentationml/2006/main">
   <p:cSld>
     <p:spTree>
       <p:nvGrpSpPr>
@@ -3264,7 +3287,14 @@
         <p:cNvGrpSpPr/>
         <p:nvPr/>
       </p:nvGrpSpPr>
-      <p:grpSpPr/>
+      <p:grpSpPr>
+        <a:xfrm>
+          <a:off x="0" y="0"/>
+          <a:ext cx="0" cy="0"/>
+          <a:chOff x="0" y="0"/>
+          <a:chExt cx="0" cy="0"/>
+        </a:xfrm>
+      </p:grpSpPr>
       <p:pic>
         <p:nvPicPr>
           <p:cNvPr id="2" name="Picture 1" descr="04-flow-payment.png"/>
@@ -3298,7 +3328,7 @@
 </file>
 
 <file path=ppt/slides/slide5.xml><?xml version="1.0" encoding="utf-8"?>
-<p:sld xmlns:a="http://schemas.openxmlformats.org/drawingml/2006/main" xmlns:p="http://schemas.openxmlformats.org/presentationml/2006/main" xmlns:r="http://schemas.openxmlformats.org/officeDocument/2006/relationships">
+<p:sld xmlns:a="http://schemas.openxmlformats.org/drawingml/2006/main" xmlns:r="http://schemas.openxmlformats.org/officeDocument/2006/relationships" xmlns:p="http://schemas.openxmlformats.org/presentationml/2006/main">
   <p:cSld>
     <p:spTree>
       <p:nvGrpSpPr>
@@ -3306,7 +3336,14 @@
         <p:cNvGrpSpPr/>
         <p:nvPr/>
       </p:nvGrpSpPr>
-      <p:grpSpPr/>
+      <p:grpSpPr>
+        <a:xfrm>
+          <a:off x="0" y="0"/>
+          <a:ext cx="0" cy="0"/>
+          <a:chOff x="0" y="0"/>
+          <a:chExt cx="0" cy="0"/>
+        </a:xfrm>
+      </p:grpSpPr>
       <p:pic>
         <p:nvPicPr>
           <p:cNvPr id="2" name="Picture 1" descr="05-flow-4potes.png"/>
@@ -3340,7 +3377,7 @@
 </file>
 
 <file path=ppt/slides/slide6.xml><?xml version="1.0" encoding="utf-8"?>
-<p:sld xmlns:a="http://schemas.openxmlformats.org/drawingml/2006/main" xmlns:p="http://schemas.openxmlformats.org/presentationml/2006/main" xmlns:r="http://schemas.openxmlformats.org/officeDocument/2006/relationships">
+<p:sld xmlns:a="http://schemas.openxmlformats.org/drawingml/2006/main" xmlns:r="http://schemas.openxmlformats.org/officeDocument/2006/relationships" xmlns:p="http://schemas.openxmlformats.org/presentationml/2006/main">
   <p:cSld>
     <p:spTree>
       <p:nvGrpSpPr>
@@ -3348,7 +3385,14 @@
         <p:cNvGrpSpPr/>
         <p:nvPr/>
       </p:nvGrpSpPr>
-      <p:grpSpPr/>
+      <p:grpSpPr>
+        <a:xfrm>
+          <a:off x="0" y="0"/>
+          <a:ext cx="0" cy="0"/>
+          <a:chOff x="0" y="0"/>
+          <a:chExt cx="0" cy="0"/>
+        </a:xfrm>
+      </p:grpSpPr>
       <p:pic>
         <p:nvPicPr>
           <p:cNvPr id="2" name="Picture 1" descr="06-flow-onboarding.png"/>
@@ -3382,7 +3426,7 @@
 </file>
 
 <file path=ppt/slides/slide7.xml><?xml version="1.0" encoding="utf-8"?>
-<p:sld xmlns:a="http://schemas.openxmlformats.org/drawingml/2006/main" xmlns:p="http://schemas.openxmlformats.org/presentationml/2006/main" xmlns:r="http://schemas.openxmlformats.org/officeDocument/2006/relationships">
+<p:sld xmlns:a="http://schemas.openxmlformats.org/drawingml/2006/main" xmlns:r="http://schemas.openxmlformats.org/officeDocument/2006/relationships" xmlns:p="http://schemas.openxmlformats.org/presentationml/2006/main">
   <p:cSld>
     <p:spTree>
       <p:nvGrpSpPr>
@@ -3390,7 +3434,14 @@
         <p:cNvGrpSpPr/>
         <p:nvPr/>
       </p:nvGrpSpPr>
-      <p:grpSpPr/>
+      <p:grpSpPr>
+        <a:xfrm>
+          <a:off x="0" y="0"/>
+          <a:ext cx="0" cy="0"/>
+          <a:chOff x="0" y="0"/>
+          <a:chExt cx="0" cy="0"/>
+        </a:xfrm>
+      </p:grpSpPr>
       <p:pic>
         <p:nvPicPr>
           <p:cNvPr id="2" name="Picture 1" descr="07-flow-ai.png"/>
@@ -3424,7 +3475,7 @@
 </file>
 
 <file path=ppt/slides/slide8.xml><?xml version="1.0" encoding="utf-8"?>
-<p:sld xmlns:a="http://schemas.openxmlformats.org/drawingml/2006/main" xmlns:p="http://schemas.openxmlformats.org/presentationml/2006/main" xmlns:r="http://schemas.openxmlformats.org/officeDocument/2006/relationships">
+<p:sld xmlns:a="http://schemas.openxmlformats.org/drawingml/2006/main" xmlns:r="http://schemas.openxmlformats.org/officeDocument/2006/relationships" xmlns:p="http://schemas.openxmlformats.org/presentationml/2006/main">
   <p:cSld>
     <p:spTree>
       <p:nvGrpSpPr>
@@ -3432,7 +3483,14 @@
         <p:cNvGrpSpPr/>
         <p:nvPr/>
       </p:nvGrpSpPr>
-      <p:grpSpPr/>
+      <p:grpSpPr>
+        <a:xfrm>
+          <a:off x="0" y="0"/>
+          <a:ext cx="0" cy="0"/>
+          <a:chOff x="0" y="0"/>
+          <a:chExt cx="0" cy="0"/>
+        </a:xfrm>
+      </p:grpSpPr>
       <p:pic>
         <p:nvPicPr>
           <p:cNvPr id="2" name="Picture 1" descr="08-security.png"/>
@@ -3466,7 +3524,7 @@
 </file>
 
 <file path=ppt/slides/slide9.xml><?xml version="1.0" encoding="utf-8"?>
-<p:sld xmlns:a="http://schemas.openxmlformats.org/drawingml/2006/main" xmlns:p="http://schemas.openxmlformats.org/presentationml/2006/main" xmlns:r="http://schemas.openxmlformats.org/officeDocument/2006/relationships">
+<p:sld xmlns:a="http://schemas.openxmlformats.org/drawingml/2006/main" xmlns:r="http://schemas.openxmlformats.org/officeDocument/2006/relationships" xmlns:p="http://schemas.openxmlformats.org/presentationml/2006/main">
   <p:cSld>
     <p:spTree>
       <p:nvGrpSpPr>
@@ -3474,7 +3532,14 @@
         <p:cNvGrpSpPr/>
         <p:nvPr/>
       </p:nvGrpSpPr>
-      <p:grpSpPr/>
+      <p:grpSpPr>
+        <a:xfrm>
+          <a:off x="0" y="0"/>
+          <a:ext cx="0" cy="0"/>
+          <a:chOff x="0" y="0"/>
+          <a:chExt cx="0" cy="0"/>
+        </a:xfrm>
+      </p:grpSpPr>
       <p:pic>
         <p:nvPicPr>
           <p:cNvPr id="2" name="Picture 1" descr="09-flow-dispute.png"/>

</xml_diff>